<commit_message>
Fix slide 3 table cell margins (were 6 inches)
Co-Authored-By: Claude Sonnet 5.5 <noreply@anthropic.com>
</commit_message>
<xml_diff>
--- a/usmeta/PROJECT_SLIDES.pptx
+++ b/usmeta/PROJECT_SLIDES.pptx
@@ -3102,7 +3102,7 @@
                       </a:endParaRPr>
                     </a:p>
                   </a:txBody>
-                  <a:tcPr marL="5486400" marR="5486400" marT="0" marB="0" anchor="ctr">
+                  <a:tcPr marL="73152" marR="73152" marT="0" marB="0" anchor="ctr">
                     <a:lnL w="0" cap="flat" cmpd="sng" algn="ctr">
                       <a:noFill/>
                     </a:lnL>
@@ -3146,7 +3146,7 @@
                       </a:endParaRPr>
                     </a:p>
                   </a:txBody>
-                  <a:tcPr marL="5486400" marR="5486400" marT="0" marB="0" anchor="ctr">
+                  <a:tcPr marL="73152" marR="73152" marT="0" marB="0" anchor="ctr">
                     <a:lnL w="0" cap="flat" cmpd="sng" algn="ctr">
                       <a:noFill/>
                     </a:lnL>
@@ -3190,7 +3190,7 @@
                       </a:endParaRPr>
                     </a:p>
                   </a:txBody>
-                  <a:tcPr marL="5486400" marR="5486400" marT="0" marB="0" anchor="ctr">
+                  <a:tcPr marL="73152" marR="73152" marT="0" marB="0" anchor="ctr">
                     <a:lnL w="0" cap="flat" cmpd="sng" algn="ctr">
                       <a:noFill/>
                     </a:lnL>
@@ -3234,7 +3234,7 @@
                       </a:endParaRPr>
                     </a:p>
                   </a:txBody>
-                  <a:tcPr marL="5486400" marR="5486400" marT="0" marB="0" anchor="ctr">
+                  <a:tcPr marL="73152" marR="73152" marT="0" marB="0" anchor="ctr">
                     <a:lnL w="0" cap="flat" cmpd="sng" algn="ctr">
                       <a:noFill/>
                     </a:lnL>
@@ -3280,7 +3280,7 @@
                       </a:endParaRPr>
                     </a:p>
                   </a:txBody>
-                  <a:tcPr marL="5486400" marR="5486400" marT="0" marB="0" anchor="ctr">
+                  <a:tcPr marL="73152" marR="73152" marT="0" marB="0" anchor="ctr">
                     <a:lnL w="0" cap="flat" cmpd="sng" algn="ctr">
                       <a:noFill/>
                     </a:lnL>
@@ -3324,7 +3324,7 @@
                       </a:endParaRPr>
                     </a:p>
                   </a:txBody>
-                  <a:tcPr marL="5486400" marR="5486400" marT="0" marB="0" anchor="ctr">
+                  <a:tcPr marL="73152" marR="73152" marT="0" marB="0" anchor="ctr">
                     <a:lnL w="0" cap="flat" cmpd="sng" algn="ctr">
                       <a:noFill/>
                     </a:lnL>
@@ -3368,7 +3368,7 @@
                       </a:endParaRPr>
                     </a:p>
                   </a:txBody>
-                  <a:tcPr marL="5486400" marR="5486400" marT="0" marB="0" anchor="ctr">
+                  <a:tcPr marL="73152" marR="73152" marT="0" marB="0" anchor="ctr">
                     <a:lnL w="0" cap="flat" cmpd="sng" algn="ctr">
                       <a:noFill/>
                     </a:lnL>
@@ -3412,7 +3412,7 @@
                       </a:endParaRPr>
                     </a:p>
                   </a:txBody>
-                  <a:tcPr marL="5486400" marR="5486400" marT="0" marB="0" anchor="ctr">
+                  <a:tcPr marL="73152" marR="73152" marT="0" marB="0" anchor="ctr">
                     <a:lnL w="0" cap="flat" cmpd="sng" algn="ctr">
                       <a:noFill/>
                     </a:lnL>
@@ -3458,7 +3458,7 @@
                       </a:endParaRPr>
                     </a:p>
                   </a:txBody>
-                  <a:tcPr marL="5486400" marR="5486400" marT="0" marB="0" anchor="ctr">
+                  <a:tcPr marL="73152" marR="73152" marT="0" marB="0" anchor="ctr">
                     <a:lnL w="0" cap="flat" cmpd="sng" algn="ctr">
                       <a:noFill/>
                     </a:lnL>
@@ -3502,7 +3502,7 @@
                       </a:endParaRPr>
                     </a:p>
                   </a:txBody>
-                  <a:tcPr marL="5486400" marR="5486400" marT="0" marB="0" anchor="ctr">
+                  <a:tcPr marL="73152" marR="73152" marT="0" marB="0" anchor="ctr">
                     <a:lnL w="0" cap="flat" cmpd="sng" algn="ctr">
                       <a:noFill/>
                     </a:lnL>
@@ -3546,7 +3546,7 @@
                       </a:endParaRPr>
                     </a:p>
                   </a:txBody>
-                  <a:tcPr marL="5486400" marR="5486400" marT="0" marB="0" anchor="ctr">
+                  <a:tcPr marL="73152" marR="73152" marT="0" marB="0" anchor="ctr">
                     <a:lnL w="0" cap="flat" cmpd="sng" algn="ctr">
                       <a:noFill/>
                     </a:lnL>
@@ -3590,7 +3590,7 @@
                       </a:endParaRPr>
                     </a:p>
                   </a:txBody>
-                  <a:tcPr marL="5486400" marR="5486400" marT="0" marB="0" anchor="ctr">
+                  <a:tcPr marL="73152" marR="73152" marT="0" marB="0" anchor="ctr">
                     <a:lnL w="0" cap="flat" cmpd="sng" algn="ctr">
                       <a:noFill/>
                     </a:lnL>
@@ -3636,7 +3636,7 @@
                       </a:endParaRPr>
                     </a:p>
                   </a:txBody>
-                  <a:tcPr marL="5486400" marR="5486400" marT="0" marB="0" anchor="ctr">
+                  <a:tcPr marL="73152" marR="73152" marT="0" marB="0" anchor="ctr">
                     <a:lnL w="0" cap="flat" cmpd="sng" algn="ctr">
                       <a:noFill/>
                     </a:lnL>
@@ -3680,7 +3680,7 @@
                       </a:endParaRPr>
                     </a:p>
                   </a:txBody>
-                  <a:tcPr marL="5486400" marR="5486400" marT="0" marB="0" anchor="ctr">
+                  <a:tcPr marL="73152" marR="73152" marT="0" marB="0" anchor="ctr">
                     <a:lnL w="0" cap="flat" cmpd="sng" algn="ctr">
                       <a:noFill/>
                     </a:lnL>
@@ -3724,7 +3724,7 @@
                       </a:endParaRPr>
                     </a:p>
                   </a:txBody>
-                  <a:tcPr marL="5486400" marR="5486400" marT="0" marB="0" anchor="ctr">
+                  <a:tcPr marL="73152" marR="73152" marT="0" marB="0" anchor="ctr">
                     <a:lnL w="0" cap="flat" cmpd="sng" algn="ctr">
                       <a:noFill/>
                     </a:lnL>
@@ -3768,7 +3768,7 @@
                       </a:endParaRPr>
                     </a:p>
                   </a:txBody>
-                  <a:tcPr marL="5486400" marR="5486400" marT="0" marB="0" anchor="ctr">
+                  <a:tcPr marL="73152" marR="73152" marT="0" marB="0" anchor="ctr">
                     <a:lnL w="0" cap="flat" cmpd="sng" algn="ctr">
                       <a:noFill/>
                     </a:lnL>
@@ -3814,7 +3814,7 @@
                       </a:endParaRPr>
                     </a:p>
                   </a:txBody>
-                  <a:tcPr marL="5486400" marR="5486400" marT="0" marB="0" anchor="ctr">
+                  <a:tcPr marL="73152" marR="73152" marT="0" marB="0" anchor="ctr">
                     <a:lnL w="0" cap="flat" cmpd="sng" algn="ctr">
                       <a:noFill/>
                     </a:lnL>
@@ -3858,7 +3858,7 @@
                       </a:endParaRPr>
                     </a:p>
                   </a:txBody>
-                  <a:tcPr marL="5486400" marR="5486400" marT="0" marB="0" anchor="ctr">
+                  <a:tcPr marL="73152" marR="73152" marT="0" marB="0" anchor="ctr">
                     <a:lnL w="0" cap="flat" cmpd="sng" algn="ctr">
                       <a:noFill/>
                     </a:lnL>
@@ -3902,7 +3902,7 @@
                       </a:endParaRPr>
                     </a:p>
                   </a:txBody>
-                  <a:tcPr marL="5486400" marR="5486400" marT="0" marB="0" anchor="ctr">
+                  <a:tcPr marL="73152" marR="73152" marT="0" marB="0" anchor="ctr">
                     <a:lnL w="0" cap="flat" cmpd="sng" algn="ctr">
                       <a:noFill/>
                     </a:lnL>
@@ -3946,7 +3946,7 @@
                       </a:endParaRPr>
                     </a:p>
                   </a:txBody>
-                  <a:tcPr marL="5486400" marR="5486400" marT="0" marB="0" anchor="ctr">
+                  <a:tcPr marL="73152" marR="73152" marT="0" marB="0" anchor="ctr">
                     <a:lnL w="0" cap="flat" cmpd="sng" algn="ctr">
                       <a:noFill/>
                     </a:lnL>
@@ -3992,7 +3992,7 @@
                       </a:endParaRPr>
                     </a:p>
                   </a:txBody>
-                  <a:tcPr marL="5486400" marR="5486400" marT="0" marB="0" anchor="ctr">
+                  <a:tcPr marL="73152" marR="73152" marT="0" marB="0" anchor="ctr">
                     <a:lnL w="0" cap="flat" cmpd="sng" algn="ctr">
                       <a:noFill/>
                     </a:lnL>
@@ -4036,7 +4036,7 @@
                       </a:endParaRPr>
                     </a:p>
                   </a:txBody>
-                  <a:tcPr marL="5486400" marR="5486400" marT="0" marB="0" anchor="ctr">
+                  <a:tcPr marL="73152" marR="73152" marT="0" marB="0" anchor="ctr">
                     <a:lnL w="0" cap="flat" cmpd="sng" algn="ctr">
                       <a:noFill/>
                     </a:lnL>
@@ -4080,7 +4080,7 @@
                       </a:endParaRPr>
                     </a:p>
                   </a:txBody>
-                  <a:tcPr marL="5486400" marR="5486400" marT="0" marB="0" anchor="ctr">
+                  <a:tcPr marL="73152" marR="73152" marT="0" marB="0" anchor="ctr">
                     <a:lnL w="0" cap="flat" cmpd="sng" algn="ctr">
                       <a:noFill/>
                     </a:lnL>
@@ -4124,7 +4124,7 @@
                       </a:endParaRPr>
                     </a:p>
                   </a:txBody>
-                  <a:tcPr marL="5486400" marR="5486400" marT="0" marB="0" anchor="ctr">
+                  <a:tcPr marL="73152" marR="73152" marT="0" marB="0" anchor="ctr">
                     <a:lnL w="0" cap="flat" cmpd="sng" algn="ctr">
                       <a:noFill/>
                     </a:lnL>
@@ -4170,7 +4170,7 @@
                       </a:endParaRPr>
                     </a:p>
                   </a:txBody>
-                  <a:tcPr marL="5486400" marR="5486400" marT="0" marB="0" anchor="ctr">
+                  <a:tcPr marL="73152" marR="73152" marT="0" marB="0" anchor="ctr">
                     <a:lnL w="0" cap="flat" cmpd="sng" algn="ctr">
                       <a:noFill/>
                     </a:lnL>
@@ -4214,7 +4214,7 @@
                       </a:endParaRPr>
                     </a:p>
                   </a:txBody>
-                  <a:tcPr marL="5486400" marR="5486400" marT="0" marB="0" anchor="ctr">
+                  <a:tcPr marL="73152" marR="73152" marT="0" marB="0" anchor="ctr">
                     <a:lnL w="0" cap="flat" cmpd="sng" algn="ctr">
                       <a:noFill/>
                     </a:lnL>
@@ -4258,7 +4258,7 @@
                       </a:endParaRPr>
                     </a:p>
                   </a:txBody>
-                  <a:tcPr marL="5486400" marR="5486400" marT="0" marB="0" anchor="ctr">
+                  <a:tcPr marL="73152" marR="73152" marT="0" marB="0" anchor="ctr">
                     <a:lnL w="0" cap="flat" cmpd="sng" algn="ctr">
                       <a:noFill/>
                     </a:lnL>
@@ -4302,7 +4302,7 @@
                       </a:endParaRPr>
                     </a:p>
                   </a:txBody>
-                  <a:tcPr marL="5486400" marR="5486400" marT="0" marB="0" anchor="ctr">
+                  <a:tcPr marL="73152" marR="73152" marT="0" marB="0" anchor="ctr">
                     <a:lnL w="0" cap="flat" cmpd="sng" algn="ctr">
                       <a:noFill/>
                     </a:lnL>
@@ -4348,7 +4348,7 @@
                       </a:endParaRPr>
                     </a:p>
                   </a:txBody>
-                  <a:tcPr marL="5486400" marR="5486400" marT="0" marB="0" anchor="ctr">
+                  <a:tcPr marL="73152" marR="73152" marT="0" marB="0" anchor="ctr">
                     <a:lnL w="0" cap="flat" cmpd="sng" algn="ctr">
                       <a:noFill/>
                     </a:lnL>
@@ -4392,7 +4392,7 @@
                       </a:endParaRPr>
                     </a:p>
                   </a:txBody>
-                  <a:tcPr marL="5486400" marR="5486400" marT="0" marB="0" anchor="ctr">
+                  <a:tcPr marL="73152" marR="73152" marT="0" marB="0" anchor="ctr">
                     <a:lnL w="0" cap="flat" cmpd="sng" algn="ctr">
                       <a:noFill/>
                     </a:lnL>
@@ -4436,7 +4436,7 @@
                       </a:endParaRPr>
                     </a:p>
                   </a:txBody>
-                  <a:tcPr marL="5486400" marR="5486400" marT="0" marB="0" anchor="ctr">
+                  <a:tcPr marL="73152" marR="73152" marT="0" marB="0" anchor="ctr">
                     <a:lnL w="0" cap="flat" cmpd="sng" algn="ctr">
                       <a:noFill/>
                     </a:lnL>
@@ -4480,7 +4480,7 @@
                       </a:endParaRPr>
                     </a:p>
                   </a:txBody>
-                  <a:tcPr marL="5486400" marR="5486400" marT="0" marB="0" anchor="ctr">
+                  <a:tcPr marL="73152" marR="73152" marT="0" marB="0" anchor="ctr">
                     <a:lnL w="0" cap="flat" cmpd="sng" algn="ctr">
                       <a:noFill/>
                     </a:lnL>
@@ -4526,7 +4526,7 @@
                       </a:endParaRPr>
                     </a:p>
                   </a:txBody>
-                  <a:tcPr marL="5486400" marR="5486400" marT="0" marB="0" anchor="ctr">
+                  <a:tcPr marL="73152" marR="73152" marT="0" marB="0" anchor="ctr">
                     <a:lnL w="0" cap="flat" cmpd="sng" algn="ctr">
                       <a:noFill/>
                     </a:lnL>
@@ -4570,7 +4570,7 @@
                       </a:endParaRPr>
                     </a:p>
                   </a:txBody>
-                  <a:tcPr marL="5486400" marR="5486400" marT="0" marB="0" anchor="ctr">
+                  <a:tcPr marL="73152" marR="73152" marT="0" marB="0" anchor="ctr">
                     <a:lnL w="0" cap="flat" cmpd="sng" algn="ctr">
                       <a:noFill/>
                     </a:lnL>
@@ -4614,7 +4614,7 @@
                       </a:endParaRPr>
                     </a:p>
                   </a:txBody>
-                  <a:tcPr marL="5486400" marR="5486400" marT="0" marB="0" anchor="ctr">
+                  <a:tcPr marL="73152" marR="73152" marT="0" marB="0" anchor="ctr">
                     <a:lnL w="0" cap="flat" cmpd="sng" algn="ctr">
                       <a:noFill/>
                     </a:lnL>
@@ -4658,7 +4658,7 @@
                       </a:endParaRPr>
                     </a:p>
                   </a:txBody>
-                  <a:tcPr marL="5486400" marR="5486400" marT="0" marB="0" anchor="ctr">
+                  <a:tcPr marL="73152" marR="73152" marT="0" marB="0" anchor="ctr">
                     <a:lnL w="0" cap="flat" cmpd="sng" algn="ctr">
                       <a:noFill/>
                     </a:lnL>
@@ -4704,7 +4704,7 @@
                       </a:endParaRPr>
                     </a:p>
                   </a:txBody>
-                  <a:tcPr marL="5486400" marR="5486400" marT="0" marB="0" anchor="ctr">
+                  <a:tcPr marL="73152" marR="73152" marT="0" marB="0" anchor="ctr">
                     <a:lnL w="0" cap="flat" cmpd="sng" algn="ctr">
                       <a:noFill/>
                     </a:lnL>
@@ -4748,7 +4748,7 @@
                       </a:endParaRPr>
                     </a:p>
                   </a:txBody>
-                  <a:tcPr marL="5486400" marR="5486400" marT="0" marB="0" anchor="ctr">
+                  <a:tcPr marL="73152" marR="73152" marT="0" marB="0" anchor="ctr">
                     <a:lnL w="0" cap="flat" cmpd="sng" algn="ctr">
                       <a:noFill/>
                     </a:lnL>
@@ -4792,7 +4792,7 @@
                       </a:endParaRPr>
                     </a:p>
                   </a:txBody>
-                  <a:tcPr marL="5486400" marR="5486400" marT="0" marB="0" anchor="ctr">
+                  <a:tcPr marL="73152" marR="73152" marT="0" marB="0" anchor="ctr">
                     <a:lnL w="0" cap="flat" cmpd="sng" algn="ctr">
                       <a:noFill/>
                     </a:lnL>
@@ -4836,7 +4836,7 @@
                       </a:endParaRPr>
                     </a:p>
                   </a:txBody>
-                  <a:tcPr marL="5486400" marR="5486400" marT="0" marB="0" anchor="ctr">
+                  <a:tcPr marL="73152" marR="73152" marT="0" marB="0" anchor="ctr">
                     <a:lnL w="0" cap="flat" cmpd="sng" algn="ctr">
                       <a:noFill/>
                     </a:lnL>
@@ -4882,7 +4882,7 @@
                       </a:endParaRPr>
                     </a:p>
                   </a:txBody>
-                  <a:tcPr marL="5486400" marR="5486400" marT="0" marB="0" anchor="ctr">
+                  <a:tcPr marL="73152" marR="73152" marT="0" marB="0" anchor="ctr">
                     <a:lnL w="0" cap="flat" cmpd="sng" algn="ctr">
                       <a:noFill/>
                     </a:lnL>
@@ -4926,7 +4926,7 @@
                       </a:endParaRPr>
                     </a:p>
                   </a:txBody>
-                  <a:tcPr marL="5486400" marR="5486400" marT="0" marB="0" anchor="ctr">
+                  <a:tcPr marL="73152" marR="73152" marT="0" marB="0" anchor="ctr">
                     <a:lnL w="0" cap="flat" cmpd="sng" algn="ctr">
                       <a:noFill/>
                     </a:lnL>
@@ -4970,7 +4970,7 @@
                       </a:endParaRPr>
                     </a:p>
                   </a:txBody>
-                  <a:tcPr marL="5486400" marR="5486400" marT="0" marB="0" anchor="ctr">
+                  <a:tcPr marL="73152" marR="73152" marT="0" marB="0" anchor="ctr">
                     <a:lnL w="0" cap="flat" cmpd="sng" algn="ctr">
                       <a:noFill/>
                     </a:lnL>
@@ -5014,7 +5014,7 @@
                       </a:endParaRPr>
                     </a:p>
                   </a:txBody>
-                  <a:tcPr marL="5486400" marR="5486400" marT="0" marB="0" anchor="ctr">
+                  <a:tcPr marL="73152" marR="73152" marT="0" marB="0" anchor="ctr">
                     <a:lnL w="0" cap="flat" cmpd="sng" algn="ctr">
                       <a:noFill/>
                     </a:lnL>

</xml_diff>